<commit_message>
WIP, syllabus up to week 6
</commit_message>
<xml_diff>
--- a/files/cs375_week1.pptx
+++ b/files/cs375_week1.pptx
@@ -5,10 +5,10 @@
     <p:sldMasterId id="2147483660" r:id="rId1"/>
   </p:sldMasterIdLst>
   <p:notesMasterIdLst>
-    <p:notesMasterId r:id="rId32"/>
+    <p:notesMasterId r:id="rId30"/>
   </p:notesMasterIdLst>
   <p:handoutMasterIdLst>
-    <p:handoutMasterId r:id="rId33"/>
+    <p:handoutMasterId r:id="rId31"/>
   </p:handoutMasterIdLst>
   <p:sldIdLst>
     <p:sldId id="256" r:id="rId2"/>
@@ -39,8 +39,6 @@
     <p:sldId id="289" r:id="rId27"/>
     <p:sldId id="290" r:id="rId28"/>
     <p:sldId id="292" r:id="rId29"/>
-    <p:sldId id="264" r:id="rId30"/>
-    <p:sldId id="265" r:id="rId31"/>
   </p:sldIdLst>
   <p:sldSz cx="12192000" cy="6858000"/>
   <p:notesSz cx="6858000" cy="9144000"/>
@@ -150,7 +148,6 @@
 <file path=ppt/revisionInfo.xml><?xml version="1.0" encoding="utf-8"?>
 <p1510:revInfo xmlns:a="http://schemas.openxmlformats.org/drawingml/2006/main" xmlns:r="http://schemas.openxmlformats.org/officeDocument/2006/relationships" xmlns:p1510="http://schemas.microsoft.com/office/powerpoint/2015/10/main">
   <p1510:revLst>
-    <p1510:client id="{7496DD31-F5A9-4994-81FD-39AB5D14D601}" v="50" dt="2026-01-24T22:37:52.762"/>
     <p1510:client id="{BD9BE298-1A5D-439C-88EB-9DD4F87EE91C}" v="15" dt="2026-01-25T20:28:40.823"/>
   </p1510:revLst>
 </p1510:revInfo>
@@ -161,7 +158,7 @@
   <pc:docChgLst>
     <pc:chgData name="Ralph Rostock" userId="ba6839b1feebeabf" providerId="LiveId" clId="{282AAF5D-1F48-4FCF-8602-3B494CE1C290}"/>
     <pc:docChg chg="undo redo custSel addSld delSld modSld sldOrd">
-      <pc:chgData name="Ralph Rostock" userId="ba6839b1feebeabf" providerId="LiveId" clId="{282AAF5D-1F48-4FCF-8602-3B494CE1C290}" dt="2026-01-25T20:37:03.892" v="5133" actId="2696"/>
+      <pc:chgData name="Ralph Rostock" userId="ba6839b1feebeabf" providerId="LiveId" clId="{282AAF5D-1F48-4FCF-8602-3B494CE1C290}" dt="2026-01-26T01:43:47.403" v="5135" actId="2696"/>
       <pc:docMkLst>
         <pc:docMk/>
       </pc:docMkLst>
@@ -240,20 +237,26 @@
           <pc:docMk/>
           <pc:sldMk cId="1647570786" sldId="261"/>
         </pc:sldMkLst>
-        <pc:spChg chg="mod">
-          <ac:chgData name="Ralph Rostock" userId="ba6839b1feebeabf" providerId="LiveId" clId="{282AAF5D-1F48-4FCF-8602-3B494CE1C290}" dt="2026-01-24T22:26:02.321" v="747" actId="1076"/>
-          <ac:spMkLst>
-            <pc:docMk/>
-            <pc:sldMk cId="1647570786" sldId="261"/>
-            <ac:spMk id="2" creationId="{FB5CDBBB-DADA-223E-6E55-D8234D44E5CC}"/>
-          </ac:spMkLst>
-        </pc:spChg>
       </pc:sldChg>
       <pc:sldChg chg="del">
         <pc:chgData name="Ralph Rostock" userId="ba6839b1feebeabf" providerId="LiveId" clId="{282AAF5D-1F48-4FCF-8602-3B494CE1C290}" dt="2026-01-25T20:09:00.696" v="4425" actId="2696"/>
         <pc:sldMkLst>
           <pc:docMk/>
           <pc:sldMk cId="3485588547" sldId="263"/>
+        </pc:sldMkLst>
+      </pc:sldChg>
+      <pc:sldChg chg="del">
+        <pc:chgData name="Ralph Rostock" userId="ba6839b1feebeabf" providerId="LiveId" clId="{282AAF5D-1F48-4FCF-8602-3B494CE1C290}" dt="2026-01-26T01:43:42.978" v="5134" actId="2696"/>
+        <pc:sldMkLst>
+          <pc:docMk/>
+          <pc:sldMk cId="4085638072" sldId="264"/>
+        </pc:sldMkLst>
+      </pc:sldChg>
+      <pc:sldChg chg="del">
+        <pc:chgData name="Ralph Rostock" userId="ba6839b1feebeabf" providerId="LiveId" clId="{282AAF5D-1F48-4FCF-8602-3B494CE1C290}" dt="2026-01-26T01:43:47.403" v="5135" actId="2696"/>
+        <pc:sldMkLst>
+          <pc:docMk/>
+          <pc:sldMk cId="3132604704" sldId="265"/>
         </pc:sldMkLst>
       </pc:sldChg>
       <pc:sldChg chg="modSp add mod ord">
@@ -299,14 +302,6 @@
             <pc:docMk/>
             <pc:sldMk cId="3596661696" sldId="267"/>
             <ac:spMk id="4" creationId="{0D314B55-9096-E7C7-6603-7D7F5E5D0F15}"/>
-          </ac:spMkLst>
-        </pc:spChg>
-        <pc:spChg chg="add mod">
-          <ac:chgData name="Ralph Rostock" userId="ba6839b1feebeabf" providerId="LiveId" clId="{282AAF5D-1F48-4FCF-8602-3B494CE1C290}" dt="2026-01-24T22:25:49.685" v="746"/>
-          <ac:spMkLst>
-            <pc:docMk/>
-            <pc:sldMk cId="3596661696" sldId="267"/>
-            <ac:spMk id="5" creationId="{38175B03-EFE3-6482-6E1C-EEADA0ADB019}"/>
           </ac:spMkLst>
         </pc:spChg>
       </pc:sldChg>
@@ -446,14 +441,6 @@
             <pc:docMk/>
             <pc:sldMk cId="3930647965" sldId="272"/>
             <ac:spMk id="3" creationId="{1C4A8219-66E7-DB44-CDD5-DB1FF99874A8}"/>
-          </ac:spMkLst>
-        </pc:spChg>
-        <pc:spChg chg="add mod">
-          <ac:chgData name="Ralph Rostock" userId="ba6839b1feebeabf" providerId="LiveId" clId="{282AAF5D-1F48-4FCF-8602-3B494CE1C290}" dt="2026-01-24T23:19:29.522" v="1676" actId="571"/>
-          <ac:spMkLst>
-            <pc:docMk/>
-            <pc:sldMk cId="3930647965" sldId="272"/>
-            <ac:spMk id="4" creationId="{46A62EA8-666C-DA50-5C11-6F019E9E76A3}"/>
           </ac:spMkLst>
         </pc:spChg>
       </pc:sldChg>
@@ -1008,7 +995,7 @@
           <a:p>
             <a:fld id="{CD76FC78-0E5D-4497-88DB-D395E4EBF0A7}" type="datetimeFigureOut">
               <a:rPr lang="en-US" smtClean="0"/>
-              <a:t>1/24/2026</a:t>
+              <a:t>1/25/2026</a:t>
             </a:fld>
             <a:endParaRPr lang="en-US"/>
           </a:p>
@@ -1189,7 +1176,7 @@
           <a:p>
             <a:fld id="{EA311FBF-2C10-463B-A9CD-21751375938C}" type="datetimeFigureOut">
               <a:rPr lang="en-US" smtClean="0"/>
-              <a:t>1/24/2026</a:t>
+              <a:t>1/25/2026</a:t>
             </a:fld>
             <a:endParaRPr lang="en-US"/>
           </a:p>
@@ -8600,36 +8587,6 @@
 </p:sld>
 </file>
 
-<file path=ppt/slides/slide29.xml><?xml version="1.0" encoding="utf-8"?>
-<p:sld xmlns:a="http://schemas.openxmlformats.org/drawingml/2006/main" xmlns:r="http://schemas.openxmlformats.org/officeDocument/2006/relationships" xmlns:p="http://schemas.openxmlformats.org/presentationml/2006/main">
-  <p:cSld>
-    <p:spTree>
-      <p:nvGrpSpPr>
-        <p:cNvPr id="1" name=""/>
-        <p:cNvGrpSpPr/>
-        <p:nvPr/>
-      </p:nvGrpSpPr>
-      <p:grpSpPr>
-        <a:xfrm>
-          <a:off x="0" y="0"/>
-          <a:ext cx="0" cy="0"/>
-          <a:chOff x="0" y="0"/>
-          <a:chExt cx="0" cy="0"/>
-        </a:xfrm>
-      </p:grpSpPr>
-    </p:spTree>
-    <p:extLst>
-      <p:ext uri="{BB962C8B-B14F-4D97-AF65-F5344CB8AC3E}">
-        <p14:creationId xmlns:p14="http://schemas.microsoft.com/office/powerpoint/2010/main" val="4085638072"/>
-      </p:ext>
-    </p:extLst>
-  </p:cSld>
-  <p:clrMapOvr>
-    <a:masterClrMapping/>
-  </p:clrMapOvr>
-</p:sld>
-</file>
-
 <file path=ppt/slides/slide3.xml><?xml version="1.0" encoding="utf-8"?>
 <p:sld xmlns:a="http://schemas.openxmlformats.org/drawingml/2006/main" xmlns:r="http://schemas.openxmlformats.org/officeDocument/2006/relationships" xmlns:p="http://schemas.openxmlformats.org/presentationml/2006/main">
   <p:cSld>
@@ -8787,36 +8744,6 @@
     <p:extLst>
       <p:ext uri="{BB962C8B-B14F-4D97-AF65-F5344CB8AC3E}">
         <p14:creationId xmlns:p14="http://schemas.microsoft.com/office/powerpoint/2010/main" val="1706386405"/>
-      </p:ext>
-    </p:extLst>
-  </p:cSld>
-  <p:clrMapOvr>
-    <a:masterClrMapping/>
-  </p:clrMapOvr>
-</p:sld>
-</file>
-
-<file path=ppt/slides/slide30.xml><?xml version="1.0" encoding="utf-8"?>
-<p:sld xmlns:a="http://schemas.openxmlformats.org/drawingml/2006/main" xmlns:r="http://schemas.openxmlformats.org/officeDocument/2006/relationships" xmlns:p="http://schemas.openxmlformats.org/presentationml/2006/main">
-  <p:cSld>
-    <p:spTree>
-      <p:nvGrpSpPr>
-        <p:cNvPr id="1" name=""/>
-        <p:cNvGrpSpPr/>
-        <p:nvPr/>
-      </p:nvGrpSpPr>
-      <p:grpSpPr>
-        <a:xfrm>
-          <a:off x="0" y="0"/>
-          <a:ext cx="0" cy="0"/>
-          <a:chOff x="0" y="0"/>
-          <a:chExt cx="0" cy="0"/>
-        </a:xfrm>
-      </p:grpSpPr>
-    </p:spTree>
-    <p:extLst>
-      <p:ext uri="{BB962C8B-B14F-4D97-AF65-F5344CB8AC3E}">
-        <p14:creationId xmlns:p14="http://schemas.microsoft.com/office/powerpoint/2010/main" val="3132604704"/>
       </p:ext>
     </p:extLst>
   </p:cSld>

</xml_diff>